<commit_message>
Deck v2 dos criadores: 14 slides, respostas às dúvidas das reuniões
Co-Authored-By: Claude Sonnet 5.5 <noreply@anthropic.com>
</commit_message>
<xml_diff>
--- a/criadores/IndicoStay-Programa-Criadores-Fundadores-PT.pptx
+++ b/criadores/IndicoStay-Programa-Criadores-Fundadores-PT.pptx
@@ -16,6 +16,9 @@
     <p:sldId id="264" r:id="rId15"/>
     <p:sldId id="265" r:id="rId16"/>
     <p:sldId id="266" r:id="rId17"/>
+    <p:sldId id="267" r:id="rId18"/>
+    <p:sldId id="268" r:id="rId19"/>
+    <p:sldId id="269" r:id="rId20"/>
   </p:sldIdLst>
   <p:sldSz cx="12191695" cy="6858000" type="screen4x3"/>
   <p:notesSz cx="6858000" cy="9144000"/>
@@ -3185,6 +3188,132 @@
       <p:pic>
         <p:nvPicPr>
           <p:cNvPr id="2" name="Picture 1" descr="hi-11.jpg"/>
+          <p:cNvPicPr>
+            <a:picLocks noChangeAspect="1"/>
+          </p:cNvPicPr>
+          <p:nvPr/>
+        </p:nvPicPr>
+        <p:blipFill>
+          <a:blip r:embed="rId2"/>
+          <a:stretch>
+            <a:fillRect/>
+          </a:stretch>
+        </p:blipFill>
+        <p:spPr>
+          <a:xfrm>
+            <a:off x="0" y="0"/>
+            <a:ext cx="12191695" cy="6858000"/>
+          </a:xfrm>
+          <a:prstGeom prst="rect">
+            <a:avLst/>
+          </a:prstGeom>
+        </p:spPr>
+      </p:pic>
+    </p:spTree>
+  </p:cSld>
+  <p:clrMapOvr>
+    <a:masterClrMapping/>
+  </p:clrMapOvr>
+</p:sld>
+</file>
+
+<file path=ppt/slides/slide12.xml><?xml version="1.0" encoding="utf-8"?>
+<p:sld xmlns:a="http://schemas.openxmlformats.org/drawingml/2006/main" xmlns:p="http://schemas.openxmlformats.org/presentationml/2006/main" xmlns:r="http://schemas.openxmlformats.org/officeDocument/2006/relationships">
+  <p:cSld>
+    <p:spTree>
+      <p:nvGrpSpPr>
+        <p:cNvPr id="1" name=""/>
+        <p:cNvGrpSpPr/>
+        <p:nvPr/>
+      </p:nvGrpSpPr>
+      <p:grpSpPr/>
+      <p:pic>
+        <p:nvPicPr>
+          <p:cNvPr id="2" name="Picture 1" descr="hi-12.jpg"/>
+          <p:cNvPicPr>
+            <a:picLocks noChangeAspect="1"/>
+          </p:cNvPicPr>
+          <p:nvPr/>
+        </p:nvPicPr>
+        <p:blipFill>
+          <a:blip r:embed="rId2"/>
+          <a:stretch>
+            <a:fillRect/>
+          </a:stretch>
+        </p:blipFill>
+        <p:spPr>
+          <a:xfrm>
+            <a:off x="0" y="0"/>
+            <a:ext cx="12191695" cy="6858000"/>
+          </a:xfrm>
+          <a:prstGeom prst="rect">
+            <a:avLst/>
+          </a:prstGeom>
+        </p:spPr>
+      </p:pic>
+    </p:spTree>
+  </p:cSld>
+  <p:clrMapOvr>
+    <a:masterClrMapping/>
+  </p:clrMapOvr>
+</p:sld>
+</file>
+
+<file path=ppt/slides/slide13.xml><?xml version="1.0" encoding="utf-8"?>
+<p:sld xmlns:a="http://schemas.openxmlformats.org/drawingml/2006/main" xmlns:p="http://schemas.openxmlformats.org/presentationml/2006/main" xmlns:r="http://schemas.openxmlformats.org/officeDocument/2006/relationships">
+  <p:cSld>
+    <p:spTree>
+      <p:nvGrpSpPr>
+        <p:cNvPr id="1" name=""/>
+        <p:cNvGrpSpPr/>
+        <p:nvPr/>
+      </p:nvGrpSpPr>
+      <p:grpSpPr/>
+      <p:pic>
+        <p:nvPicPr>
+          <p:cNvPr id="2" name="Picture 1" descr="hi-13.jpg"/>
+          <p:cNvPicPr>
+            <a:picLocks noChangeAspect="1"/>
+          </p:cNvPicPr>
+          <p:nvPr/>
+        </p:nvPicPr>
+        <p:blipFill>
+          <a:blip r:embed="rId2"/>
+          <a:stretch>
+            <a:fillRect/>
+          </a:stretch>
+        </p:blipFill>
+        <p:spPr>
+          <a:xfrm>
+            <a:off x="0" y="0"/>
+            <a:ext cx="12191695" cy="6858000"/>
+          </a:xfrm>
+          <a:prstGeom prst="rect">
+            <a:avLst/>
+          </a:prstGeom>
+        </p:spPr>
+      </p:pic>
+    </p:spTree>
+  </p:cSld>
+  <p:clrMapOvr>
+    <a:masterClrMapping/>
+  </p:clrMapOvr>
+</p:sld>
+</file>
+
+<file path=ppt/slides/slide14.xml><?xml version="1.0" encoding="utf-8"?>
+<p:sld xmlns:a="http://schemas.openxmlformats.org/drawingml/2006/main" xmlns:p="http://schemas.openxmlformats.org/presentationml/2006/main" xmlns:r="http://schemas.openxmlformats.org/officeDocument/2006/relationships">
+  <p:cSld>
+    <p:spTree>
+      <p:nvGrpSpPr>
+        <p:cNvPr id="1" name=""/>
+        <p:cNvGrpSpPr/>
+        <p:nvPr/>
+      </p:nvGrpSpPr>
+      <p:grpSpPr/>
+      <p:pic>
+        <p:nvPicPr>
+          <p:cNvPr id="2" name="Picture 1" descr="hi-14.jpg"/>
           <p:cNvPicPr>
             <a:picLocks noChangeAspect="1"/>
           </p:cNvPicPr>

</xml_diff>

<commit_message>
Deck v2: duas demonstrações ao vivo (app, painel e simulador)
Co-Authored-By: Claude Sonnet 5.5 <noreply@anthropic.com>
</commit_message>
<xml_diff>
--- a/criadores/IndicoStay-Programa-Criadores-Fundadores-PT.pptx
+++ b/criadores/IndicoStay-Programa-Criadores-Fundadores-PT.pptx
@@ -19,6 +19,8 @@
     <p:sldId id="267" r:id="rId18"/>
     <p:sldId id="268" r:id="rId19"/>
     <p:sldId id="269" r:id="rId20"/>
+    <p:sldId id="270" r:id="rId21"/>
+    <p:sldId id="271" r:id="rId22"/>
   </p:sldIdLst>
   <p:sldSz cx="12191695" cy="6858000" type="screen4x3"/>
   <p:notesSz cx="6858000" cy="9144000"/>
@@ -3314,6 +3316,90 @@
       <p:pic>
         <p:nvPicPr>
           <p:cNvPr id="2" name="Picture 1" descr="hi-14.jpg"/>
+          <p:cNvPicPr>
+            <a:picLocks noChangeAspect="1"/>
+          </p:cNvPicPr>
+          <p:nvPr/>
+        </p:nvPicPr>
+        <p:blipFill>
+          <a:blip r:embed="rId2"/>
+          <a:stretch>
+            <a:fillRect/>
+          </a:stretch>
+        </p:blipFill>
+        <p:spPr>
+          <a:xfrm>
+            <a:off x="0" y="0"/>
+            <a:ext cx="12191695" cy="6858000"/>
+          </a:xfrm>
+          <a:prstGeom prst="rect">
+            <a:avLst/>
+          </a:prstGeom>
+        </p:spPr>
+      </p:pic>
+    </p:spTree>
+  </p:cSld>
+  <p:clrMapOvr>
+    <a:masterClrMapping/>
+  </p:clrMapOvr>
+</p:sld>
+</file>
+
+<file path=ppt/slides/slide15.xml><?xml version="1.0" encoding="utf-8"?>
+<p:sld xmlns:a="http://schemas.openxmlformats.org/drawingml/2006/main" xmlns:p="http://schemas.openxmlformats.org/presentationml/2006/main" xmlns:r="http://schemas.openxmlformats.org/officeDocument/2006/relationships">
+  <p:cSld>
+    <p:spTree>
+      <p:nvGrpSpPr>
+        <p:cNvPr id="1" name=""/>
+        <p:cNvGrpSpPr/>
+        <p:nvPr/>
+      </p:nvGrpSpPr>
+      <p:grpSpPr/>
+      <p:pic>
+        <p:nvPicPr>
+          <p:cNvPr id="2" name="Picture 1" descr="hi-15.jpg"/>
+          <p:cNvPicPr>
+            <a:picLocks noChangeAspect="1"/>
+          </p:cNvPicPr>
+          <p:nvPr/>
+        </p:nvPicPr>
+        <p:blipFill>
+          <a:blip r:embed="rId2"/>
+          <a:stretch>
+            <a:fillRect/>
+          </a:stretch>
+        </p:blipFill>
+        <p:spPr>
+          <a:xfrm>
+            <a:off x="0" y="0"/>
+            <a:ext cx="12191695" cy="6858000"/>
+          </a:xfrm>
+          <a:prstGeom prst="rect">
+            <a:avLst/>
+          </a:prstGeom>
+        </p:spPr>
+      </p:pic>
+    </p:spTree>
+  </p:cSld>
+  <p:clrMapOvr>
+    <a:masterClrMapping/>
+  </p:clrMapOvr>
+</p:sld>
+</file>
+
+<file path=ppt/slides/slide16.xml><?xml version="1.0" encoding="utf-8"?>
+<p:sld xmlns:a="http://schemas.openxmlformats.org/drawingml/2006/main" xmlns:p="http://schemas.openxmlformats.org/presentationml/2006/main" xmlns:r="http://schemas.openxmlformats.org/officeDocument/2006/relationships">
+  <p:cSld>
+    <p:spTree>
+      <p:nvGrpSpPr>
+        <p:cNvPr id="1" name=""/>
+        <p:cNvGrpSpPr/>
+        <p:nvPr/>
+      </p:nvGrpSpPr>
+      <p:grpSpPr/>
+      <p:pic>
+        <p:nvPicPr>
+          <p:cNvPr id="2" name="Picture 1" descr="hi-16.jpg"/>
           <p:cNvPicPr>
             <a:picLocks noChangeAspect="1"/>
           </p:cNvPicPr>

</xml_diff>

<commit_message>
Calculators and deck: 1 stay per reservation, commission in the month of booking, no 6-month spreading
Co-Authored-By: Claude Sonnet 5.5 <noreply@anthropic.com>
</commit_message>
<xml_diff>
--- a/criadores/IndicoStay-Programa-Criadores-Fundadores-PT.pptx
+++ b/criadores/IndicoStay-Programa-Criadores-Fundadores-PT.pptx
@@ -3105,7 +3105,7 @@
       <p:grpSpPr/>
       <p:pic>
         <p:nvPicPr>
-          <p:cNvPr id="2" name="Picture 1" descr="hi-01.jpg"/>
+          <p:cNvPr id="2" name="Picture 1" descr="n-01.jpg"/>
           <p:cNvPicPr>
             <a:picLocks noChangeAspect="1"/>
           </p:cNvPicPr>
@@ -3147,7 +3147,7 @@
       <p:grpSpPr/>
       <p:pic>
         <p:nvPicPr>
-          <p:cNvPr id="2" name="Picture 1" descr="hi-10.jpg"/>
+          <p:cNvPr id="2" name="Picture 1" descr="n-10.jpg"/>
           <p:cNvPicPr>
             <a:picLocks noChangeAspect="1"/>
           </p:cNvPicPr>
@@ -3189,7 +3189,7 @@
       <p:grpSpPr/>
       <p:pic>
         <p:nvPicPr>
-          <p:cNvPr id="2" name="Picture 1" descr="hi-11.jpg"/>
+          <p:cNvPr id="2" name="Picture 1" descr="n-11.jpg"/>
           <p:cNvPicPr>
             <a:picLocks noChangeAspect="1"/>
           </p:cNvPicPr>
@@ -3231,7 +3231,7 @@
       <p:grpSpPr/>
       <p:pic>
         <p:nvPicPr>
-          <p:cNvPr id="2" name="Picture 1" descr="hi-12.jpg"/>
+          <p:cNvPr id="2" name="Picture 1" descr="n-12.jpg"/>
           <p:cNvPicPr>
             <a:picLocks noChangeAspect="1"/>
           </p:cNvPicPr>
@@ -3273,7 +3273,7 @@
       <p:grpSpPr/>
       <p:pic>
         <p:nvPicPr>
-          <p:cNvPr id="2" name="Picture 1" descr="hi-13.jpg"/>
+          <p:cNvPr id="2" name="Picture 1" descr="n-13.jpg"/>
           <p:cNvPicPr>
             <a:picLocks noChangeAspect="1"/>
           </p:cNvPicPr>
@@ -3315,7 +3315,7 @@
       <p:grpSpPr/>
       <p:pic>
         <p:nvPicPr>
-          <p:cNvPr id="2" name="Picture 1" descr="hi-14.jpg"/>
+          <p:cNvPr id="2" name="Picture 1" descr="n-14.jpg"/>
           <p:cNvPicPr>
             <a:picLocks noChangeAspect="1"/>
           </p:cNvPicPr>
@@ -3357,7 +3357,7 @@
       <p:grpSpPr/>
       <p:pic>
         <p:nvPicPr>
-          <p:cNvPr id="2" name="Picture 1" descr="hi-15.jpg"/>
+          <p:cNvPr id="2" name="Picture 1" descr="n-15.jpg"/>
           <p:cNvPicPr>
             <a:picLocks noChangeAspect="1"/>
           </p:cNvPicPr>
@@ -3399,7 +3399,7 @@
       <p:grpSpPr/>
       <p:pic>
         <p:nvPicPr>
-          <p:cNvPr id="2" name="Picture 1" descr="hi-16.jpg"/>
+          <p:cNvPr id="2" name="Picture 1" descr="n-16.jpg"/>
           <p:cNvPicPr>
             <a:picLocks noChangeAspect="1"/>
           </p:cNvPicPr>
@@ -3441,7 +3441,7 @@
       <p:grpSpPr/>
       <p:pic>
         <p:nvPicPr>
-          <p:cNvPr id="2" name="Picture 1" descr="hi-02.jpg"/>
+          <p:cNvPr id="2" name="Picture 1" descr="n-02.jpg"/>
           <p:cNvPicPr>
             <a:picLocks noChangeAspect="1"/>
           </p:cNvPicPr>
@@ -3483,7 +3483,7 @@
       <p:grpSpPr/>
       <p:pic>
         <p:nvPicPr>
-          <p:cNvPr id="2" name="Picture 1" descr="hi-03.jpg"/>
+          <p:cNvPr id="2" name="Picture 1" descr="n-03.jpg"/>
           <p:cNvPicPr>
             <a:picLocks noChangeAspect="1"/>
           </p:cNvPicPr>
@@ -3525,7 +3525,7 @@
       <p:grpSpPr/>
       <p:pic>
         <p:nvPicPr>
-          <p:cNvPr id="2" name="Picture 1" descr="hi-04.jpg"/>
+          <p:cNvPr id="2" name="Picture 1" descr="n-04.jpg"/>
           <p:cNvPicPr>
             <a:picLocks noChangeAspect="1"/>
           </p:cNvPicPr>
@@ -3567,7 +3567,7 @@
       <p:grpSpPr/>
       <p:pic>
         <p:nvPicPr>
-          <p:cNvPr id="2" name="Picture 1" descr="hi-05.jpg"/>
+          <p:cNvPr id="2" name="Picture 1" descr="n-05.jpg"/>
           <p:cNvPicPr>
             <a:picLocks noChangeAspect="1"/>
           </p:cNvPicPr>
@@ -3609,7 +3609,7 @@
       <p:grpSpPr/>
       <p:pic>
         <p:nvPicPr>
-          <p:cNvPr id="2" name="Picture 1" descr="hi-06.jpg"/>
+          <p:cNvPr id="2" name="Picture 1" descr="n-06.jpg"/>
           <p:cNvPicPr>
             <a:picLocks noChangeAspect="1"/>
           </p:cNvPicPr>
@@ -3651,7 +3651,7 @@
       <p:grpSpPr/>
       <p:pic>
         <p:nvPicPr>
-          <p:cNvPr id="2" name="Picture 1" descr="hi-07.jpg"/>
+          <p:cNvPr id="2" name="Picture 1" descr="n-07.jpg"/>
           <p:cNvPicPr>
             <a:picLocks noChangeAspect="1"/>
           </p:cNvPicPr>
@@ -3693,7 +3693,7 @@
       <p:grpSpPr/>
       <p:pic>
         <p:nvPicPr>
-          <p:cNvPr id="2" name="Picture 1" descr="hi-08.jpg"/>
+          <p:cNvPr id="2" name="Picture 1" descr="n-08.jpg"/>
           <p:cNvPicPr>
             <a:picLocks noChangeAspect="1"/>
           </p:cNvPicPr>
@@ -3735,7 +3735,7 @@
       <p:grpSpPr/>
       <p:pic>
         <p:nvPicPr>
-          <p:cNvPr id="2" name="Picture 1" descr="hi-09.jpg"/>
+          <p:cNvPr id="2" name="Picture 1" descr="n-09.jpg"/>
           <p:cNvPicPr>
             <a:picLocks noChangeAspect="1"/>
           </p:cNvPicPr>

</xml_diff>